<commit_message>
Add age condition analysis (S11) to market deck
- Extract 年齢上限/下限/年齢不問/世代キーワード from job text
- S11 slide: KPI boxes + age limit distribution + generation targeting %
  + category-level median age bar chart
- 12 slides total

Co-Authored-By: Claude Opus 4.6 <noreply@anthropic.com>
Claude-Session: https://claude.ai/code/session_01AizXArbN25UVwZNTkES5qE
</commit_message>
<xml_diff>
--- a/建設業界_採用市場調査v2.pptx
+++ b/建設業界_採用市場調査v2.pptx
@@ -16,6 +16,7 @@
     <p:sldId id="264" r:id="rId15"/>
     <p:sldId id="265" r:id="rId16"/>
     <p:sldId id="266" r:id="rId17"/>
+    <p:sldId id="267" r:id="rId18"/>
   </p:sldIdLst>
   <p:sldSz cx="12188952" cy="6858000" type="screen4x3"/>
   <p:notesSz cx="6858000" cy="9144000"/>
@@ -5498,6 +5499,1221 @@
           <a:xfrm>
             <a:off x="5486400" y="1874519"/>
             <a:ext cx="6492240" cy="4617720"/>
+          </a:xfrm>
+          <a:prstGeom prst="rect">
+            <a:avLst/>
+          </a:prstGeom>
+        </p:spPr>
+      </p:pic>
+    </p:spTree>
+  </p:cSld>
+  <p:clrMapOvr>
+    <a:masterClrMapping/>
+  </p:clrMapOvr>
+</p:sld>
+</file>
+
+<file path=ppt/slides/slide12.xml><?xml version="1.0" encoding="utf-8"?>
+<p:sld xmlns:a="http://schemas.openxmlformats.org/drawingml/2006/main" xmlns:p="http://schemas.openxmlformats.org/presentationml/2006/main" xmlns:r="http://schemas.openxmlformats.org/officeDocument/2006/relationships">
+  <p:cSld>
+    <p:spTree>
+      <p:nvGrpSpPr>
+        <p:cNvPr id="1" name=""/>
+        <p:cNvGrpSpPr/>
+        <p:nvPr/>
+      </p:nvGrpSpPr>
+      <p:grpSpPr/>
+      <p:sp>
+        <p:nvSpPr>
+          <p:cNvPr id="2" name="Rectangle 1"/>
+          <p:cNvSpPr/>
+          <p:nvPr/>
+        </p:nvSpPr>
+        <p:spPr>
+          <a:xfrm>
+            <a:off x="0" y="0"/>
+            <a:ext cx="12188952" cy="6858000"/>
+          </a:xfrm>
+          <a:prstGeom prst="rect">
+            <a:avLst/>
+          </a:prstGeom>
+          <a:solidFill>
+            <a:srgbClr val="FFFFFF"/>
+          </a:solidFill>
+          <a:ln>
+            <a:noFill/>
+          </a:ln>
+        </p:spPr>
+        <p:style>
+          <a:lnRef idx="1">
+            <a:schemeClr val="accent1"/>
+          </a:lnRef>
+          <a:fillRef idx="3">
+            <a:schemeClr val="accent1"/>
+          </a:fillRef>
+          <a:effectRef idx="2">
+            <a:schemeClr val="accent1"/>
+          </a:effectRef>
+          <a:fontRef idx="minor">
+            <a:schemeClr val="lt1"/>
+          </a:fontRef>
+        </p:style>
+        <p:txBody>
+          <a:bodyPr rtlCol="0" anchor="ctr"/>
+          <a:lstStyle/>
+          <a:p>
+            <a:pPr algn="ctr"/>
+          </a:p>
+        </p:txBody>
+      </p:sp>
+      <p:sp>
+        <p:nvSpPr>
+          <p:cNvPr id="3" name="Rectangle 2"/>
+          <p:cNvSpPr/>
+          <p:nvPr/>
+        </p:nvSpPr>
+        <p:spPr>
+          <a:xfrm>
+            <a:off x="201168" y="164592"/>
+            <a:ext cx="64008" cy="438912"/>
+          </a:xfrm>
+          <a:prstGeom prst="rect">
+            <a:avLst/>
+          </a:prstGeom>
+          <a:solidFill>
+            <a:srgbClr val="1A3460"/>
+          </a:solidFill>
+          <a:ln>
+            <a:noFill/>
+          </a:ln>
+        </p:spPr>
+        <p:style>
+          <a:lnRef idx="1">
+            <a:schemeClr val="accent1"/>
+          </a:lnRef>
+          <a:fillRef idx="3">
+            <a:schemeClr val="accent1"/>
+          </a:fillRef>
+          <a:effectRef idx="2">
+            <a:schemeClr val="accent1"/>
+          </a:effectRef>
+          <a:fontRef idx="minor">
+            <a:schemeClr val="lt1"/>
+          </a:fontRef>
+        </p:style>
+        <p:txBody>
+          <a:bodyPr rtlCol="0" anchor="ctr"/>
+          <a:lstStyle/>
+          <a:p>
+            <a:pPr algn="ctr"/>
+          </a:p>
+        </p:txBody>
+      </p:sp>
+      <p:sp>
+        <p:nvSpPr>
+          <p:cNvPr id="4" name="TextBox 3"/>
+          <p:cNvSpPr txBox="1"/>
+          <p:nvPr/>
+        </p:nvSpPr>
+        <p:spPr>
+          <a:xfrm>
+            <a:off x="347472" y="155448"/>
+            <a:ext cx="9601200" cy="475488"/>
+          </a:xfrm>
+          <a:prstGeom prst="rect">
+            <a:avLst/>
+          </a:prstGeom>
+          <a:noFill/>
+        </p:spPr>
+        <p:txBody>
+          <a:bodyPr wrap="square">
+            <a:spAutoFit/>
+          </a:bodyPr>
+          <a:lstStyle/>
+          <a:p>
+            <a:pPr algn="l"/>
+            <a:r>
+              <a:rPr sz="1700" b="1" i="0">
+                <a:solidFill>
+                  <a:srgbClr val="1A3460"/>
+                </a:solidFill>
+                <a:latin typeface="メイリオ"/>
+              </a:rPr>
+              <a:t>年齢条件の記載状況（N=10,526件）：上限年齢・世代訴求・年齢不問の分布</a:t>
+            </a:r>
+          </a:p>
+        </p:txBody>
+      </p:sp>
+      <p:sp>
+        <p:nvSpPr>
+          <p:cNvPr id="5" name="TextBox 4"/>
+          <p:cNvSpPr txBox="1"/>
+          <p:nvPr/>
+        </p:nvSpPr>
+        <p:spPr>
+          <a:xfrm>
+            <a:off x="9601200" y="182880"/>
+            <a:ext cx="2423160" cy="320040"/>
+          </a:xfrm>
+          <a:prstGeom prst="rect">
+            <a:avLst/>
+          </a:prstGeom>
+          <a:noFill/>
+        </p:spPr>
+        <p:txBody>
+          <a:bodyPr wrap="square">
+            <a:spAutoFit/>
+          </a:bodyPr>
+          <a:lstStyle/>
+          <a:p>
+            <a:pPr algn="r"/>
+            <a:r>
+              <a:rPr sz="800" b="0" i="0">
+                <a:solidFill>
+                  <a:srgbClr val="6B7280"/>
+                </a:solidFill>
+                <a:latin typeface="メイリオ"/>
+              </a:rPr>
+              <a:t>🎂 Age Condition Analysis</a:t>
+            </a:r>
+          </a:p>
+        </p:txBody>
+      </p:sp>
+      <p:sp>
+        <p:nvSpPr>
+          <p:cNvPr id="6" name="Rectangle 5"/>
+          <p:cNvSpPr/>
+          <p:nvPr/>
+        </p:nvSpPr>
+        <p:spPr>
+          <a:xfrm>
+            <a:off x="201168" y="685800"/>
+            <a:ext cx="11887200" cy="18288"/>
+          </a:xfrm>
+          <a:prstGeom prst="rect">
+            <a:avLst/>
+          </a:prstGeom>
+          <a:solidFill>
+            <a:srgbClr val="D1D5DB"/>
+          </a:solidFill>
+          <a:ln>
+            <a:noFill/>
+          </a:ln>
+        </p:spPr>
+        <p:style>
+          <a:lnRef idx="1">
+            <a:schemeClr val="accent1"/>
+          </a:lnRef>
+          <a:fillRef idx="3">
+            <a:schemeClr val="accent1"/>
+          </a:fillRef>
+          <a:effectRef idx="2">
+            <a:schemeClr val="accent1"/>
+          </a:effectRef>
+          <a:fontRef idx="minor">
+            <a:schemeClr val="lt1"/>
+          </a:fontRef>
+        </p:style>
+        <p:txBody>
+          <a:bodyPr rtlCol="0" anchor="ctr"/>
+          <a:lstStyle/>
+          <a:p>
+            <a:pPr algn="ctr"/>
+          </a:p>
+        </p:txBody>
+      </p:sp>
+      <p:sp>
+        <p:nvSpPr>
+          <p:cNvPr id="7" name="Rectangle 6"/>
+          <p:cNvSpPr/>
+          <p:nvPr/>
+        </p:nvSpPr>
+        <p:spPr>
+          <a:xfrm>
+            <a:off x="0" y="6537960"/>
+            <a:ext cx="12188952" cy="320040"/>
+          </a:xfrm>
+          <a:prstGeom prst="rect">
+            <a:avLst/>
+          </a:prstGeom>
+          <a:solidFill>
+            <a:srgbClr val="F3F4F6"/>
+          </a:solidFill>
+          <a:ln>
+            <a:noFill/>
+          </a:ln>
+        </p:spPr>
+        <p:style>
+          <a:lnRef idx="1">
+            <a:schemeClr val="accent1"/>
+          </a:lnRef>
+          <a:fillRef idx="3">
+            <a:schemeClr val="accent1"/>
+          </a:fillRef>
+          <a:effectRef idx="2">
+            <a:schemeClr val="accent1"/>
+          </a:effectRef>
+          <a:fontRef idx="minor">
+            <a:schemeClr val="lt1"/>
+          </a:fontRef>
+        </p:style>
+        <p:txBody>
+          <a:bodyPr rtlCol="0" anchor="ctr"/>
+          <a:lstStyle/>
+          <a:p>
+            <a:pPr algn="ctr"/>
+          </a:p>
+        </p:txBody>
+      </p:sp>
+      <p:sp>
+        <p:nvSpPr>
+          <p:cNvPr id="8" name="TextBox 7"/>
+          <p:cNvSpPr txBox="1"/>
+          <p:nvPr/>
+        </p:nvSpPr>
+        <p:spPr>
+          <a:xfrm>
+            <a:off x="274320" y="6583680"/>
+            <a:ext cx="10058400" cy="228600"/>
+          </a:xfrm>
+          <a:prstGeom prst="rect">
+            <a:avLst/>
+          </a:prstGeom>
+          <a:noFill/>
+        </p:spPr>
+        <p:txBody>
+          <a:bodyPr wrap="square">
+            <a:spAutoFit/>
+          </a:bodyPr>
+          <a:lstStyle/>
+          <a:p>
+            <a:pPr algn="l"/>
+            <a:r>
+              <a:rPr sz="750" b="0" i="0">
+                <a:solidFill>
+                  <a:srgbClr val="6B7280"/>
+                </a:solidFill>
+                <a:latin typeface="メイリオ"/>
+              </a:rPr>
+              <a:t>※ r-agent 求人掲載データ（2024年）に基づく分析。掲載件数N=10,526件。</a:t>
+            </a:r>
+          </a:p>
+        </p:txBody>
+      </p:sp>
+      <p:sp>
+        <p:nvSpPr>
+          <p:cNvPr id="9" name="TextBox 8"/>
+          <p:cNvSpPr txBox="1"/>
+          <p:nvPr/>
+        </p:nvSpPr>
+        <p:spPr>
+          <a:xfrm>
+            <a:off x="11704320" y="6583680"/>
+            <a:ext cx="365760" cy="228600"/>
+          </a:xfrm>
+          <a:prstGeom prst="rect">
+            <a:avLst/>
+          </a:prstGeom>
+          <a:noFill/>
+        </p:spPr>
+        <p:txBody>
+          <a:bodyPr wrap="square">
+            <a:spAutoFit/>
+          </a:bodyPr>
+          <a:lstStyle/>
+          <a:p>
+            <a:pPr algn="r"/>
+            <a:r>
+              <a:rPr sz="800" b="0" i="0">
+                <a:solidFill>
+                  <a:srgbClr val="6B7280"/>
+                </a:solidFill>
+                <a:latin typeface="メイリオ"/>
+              </a:rPr>
+              <a:t>11</a:t>
+            </a:r>
+          </a:p>
+        </p:txBody>
+      </p:sp>
+      <p:sp>
+        <p:nvSpPr>
+          <p:cNvPr id="10" name="Rectangle 9"/>
+          <p:cNvSpPr/>
+          <p:nvPr/>
+        </p:nvSpPr>
+        <p:spPr>
+          <a:xfrm>
+            <a:off x="201168" y="822960"/>
+            <a:ext cx="3474720" cy="914400"/>
+          </a:xfrm>
+          <a:prstGeom prst="rect">
+            <a:avLst/>
+          </a:prstGeom>
+          <a:solidFill>
+            <a:srgbClr val="FFFFFF"/>
+          </a:solidFill>
+          <a:ln>
+            <a:solidFill>
+              <a:srgbClr val="D1D5DB"/>
+            </a:solidFill>
+          </a:ln>
+        </p:spPr>
+        <p:style>
+          <a:lnRef idx="1">
+            <a:schemeClr val="accent1"/>
+          </a:lnRef>
+          <a:fillRef idx="3">
+            <a:schemeClr val="accent1"/>
+          </a:fillRef>
+          <a:effectRef idx="2">
+            <a:schemeClr val="accent1"/>
+          </a:effectRef>
+          <a:fontRef idx="minor">
+            <a:schemeClr val="lt1"/>
+          </a:fontRef>
+        </p:style>
+        <p:txBody>
+          <a:bodyPr rtlCol="0" anchor="ctr"/>
+          <a:lstStyle/>
+          <a:p>
+            <a:pPr algn="ctr"/>
+          </a:p>
+        </p:txBody>
+      </p:sp>
+      <p:sp>
+        <p:nvSpPr>
+          <p:cNvPr id="11" name="Rectangle 10"/>
+          <p:cNvSpPr/>
+          <p:nvPr/>
+        </p:nvSpPr>
+        <p:spPr>
+          <a:xfrm>
+            <a:off x="201168" y="822960"/>
+            <a:ext cx="3474720" cy="50292"/>
+          </a:xfrm>
+          <a:prstGeom prst="rect">
+            <a:avLst/>
+          </a:prstGeom>
+          <a:solidFill>
+            <a:srgbClr val="2163EB"/>
+          </a:solidFill>
+          <a:ln>
+            <a:noFill/>
+          </a:ln>
+        </p:spPr>
+        <p:style>
+          <a:lnRef idx="1">
+            <a:schemeClr val="accent1"/>
+          </a:lnRef>
+          <a:fillRef idx="3">
+            <a:schemeClr val="accent1"/>
+          </a:fillRef>
+          <a:effectRef idx="2">
+            <a:schemeClr val="accent1"/>
+          </a:effectRef>
+          <a:fontRef idx="minor">
+            <a:schemeClr val="lt1"/>
+          </a:fontRef>
+        </p:style>
+        <p:txBody>
+          <a:bodyPr rtlCol="0" anchor="ctr"/>
+          <a:lstStyle/>
+          <a:p>
+            <a:pPr algn="ctr"/>
+          </a:p>
+        </p:txBody>
+      </p:sp>
+      <p:sp>
+        <p:nvSpPr>
+          <p:cNvPr id="12" name="TextBox 11"/>
+          <p:cNvSpPr txBox="1"/>
+          <p:nvPr/>
+        </p:nvSpPr>
+        <p:spPr>
+          <a:xfrm>
+            <a:off x="365760" y="914400"/>
+            <a:ext cx="3246120" cy="256032"/>
+          </a:xfrm>
+          <a:prstGeom prst="rect">
+            <a:avLst/>
+          </a:prstGeom>
+          <a:noFill/>
+        </p:spPr>
+        <p:txBody>
+          <a:bodyPr wrap="square">
+            <a:spAutoFit/>
+          </a:bodyPr>
+          <a:lstStyle/>
+          <a:p>
+            <a:pPr algn="l"/>
+            <a:r>
+              <a:rPr sz="900" b="0" i="0">
+                <a:solidFill>
+                  <a:srgbClr val="6B7280"/>
+                </a:solidFill>
+                <a:latin typeface="メイリオ"/>
+              </a:rPr>
+              <a:t>年齢上限 記載あり</a:t>
+            </a:r>
+          </a:p>
+        </p:txBody>
+      </p:sp>
+      <p:sp>
+        <p:nvSpPr>
+          <p:cNvPr id="13" name="TextBox 12"/>
+          <p:cNvSpPr txBox="1"/>
+          <p:nvPr/>
+        </p:nvSpPr>
+        <p:spPr>
+          <a:xfrm>
+            <a:off x="365760" y="1170432"/>
+            <a:ext cx="2971800" cy="457200"/>
+          </a:xfrm>
+          <a:prstGeom prst="rect">
+            <a:avLst/>
+          </a:prstGeom>
+          <a:noFill/>
+        </p:spPr>
+        <p:txBody>
+          <a:bodyPr wrap="square">
+            <a:spAutoFit/>
+          </a:bodyPr>
+          <a:lstStyle/>
+          <a:p>
+            <a:pPr algn="l"/>
+            <a:r>
+              <a:rPr sz="2600" b="1" i="0">
+                <a:solidFill>
+                  <a:srgbClr val="1A3460"/>
+                </a:solidFill>
+                <a:latin typeface="メイリオ"/>
+              </a:rPr>
+              <a:t>1.3</a:t>
+            </a:r>
+          </a:p>
+        </p:txBody>
+      </p:sp>
+      <p:sp>
+        <p:nvSpPr>
+          <p:cNvPr id="14" name="TextBox 13"/>
+          <p:cNvSpPr txBox="1"/>
+          <p:nvPr/>
+        </p:nvSpPr>
+        <p:spPr>
+          <a:xfrm>
+            <a:off x="886968" y="1325880"/>
+            <a:ext cx="1097280" cy="256032"/>
+          </a:xfrm>
+          <a:prstGeom prst="rect">
+            <a:avLst/>
+          </a:prstGeom>
+          <a:noFill/>
+        </p:spPr>
+        <p:txBody>
+          <a:bodyPr wrap="square">
+            <a:spAutoFit/>
+          </a:bodyPr>
+          <a:lstStyle/>
+          <a:p>
+            <a:pPr algn="l"/>
+            <a:r>
+              <a:rPr sz="1100" b="0" i="0">
+                <a:solidFill>
+                  <a:srgbClr val="6B7280"/>
+                </a:solidFill>
+                <a:latin typeface="メイリオ"/>
+              </a:rPr>
+              <a:t>%</a:t>
+            </a:r>
+          </a:p>
+        </p:txBody>
+      </p:sp>
+      <p:sp>
+        <p:nvSpPr>
+          <p:cNvPr id="15" name="Rectangle 14"/>
+          <p:cNvSpPr/>
+          <p:nvPr/>
+        </p:nvSpPr>
+        <p:spPr>
+          <a:xfrm>
+            <a:off x="3904487" y="822960"/>
+            <a:ext cx="3474720" cy="914400"/>
+          </a:xfrm>
+          <a:prstGeom prst="rect">
+            <a:avLst/>
+          </a:prstGeom>
+          <a:solidFill>
+            <a:srgbClr val="FFFFFF"/>
+          </a:solidFill>
+          <a:ln>
+            <a:solidFill>
+              <a:srgbClr val="D1D5DB"/>
+            </a:solidFill>
+          </a:ln>
+        </p:spPr>
+        <p:style>
+          <a:lnRef idx="1">
+            <a:schemeClr val="accent1"/>
+          </a:lnRef>
+          <a:fillRef idx="3">
+            <a:schemeClr val="accent1"/>
+          </a:fillRef>
+          <a:effectRef idx="2">
+            <a:schemeClr val="accent1"/>
+          </a:effectRef>
+          <a:fontRef idx="minor">
+            <a:schemeClr val="lt1"/>
+          </a:fontRef>
+        </p:style>
+        <p:txBody>
+          <a:bodyPr rtlCol="0" anchor="ctr"/>
+          <a:lstStyle/>
+          <a:p>
+            <a:pPr algn="ctr"/>
+          </a:p>
+        </p:txBody>
+      </p:sp>
+      <p:sp>
+        <p:nvSpPr>
+          <p:cNvPr id="16" name="Rectangle 15"/>
+          <p:cNvSpPr/>
+          <p:nvPr/>
+        </p:nvSpPr>
+        <p:spPr>
+          <a:xfrm>
+            <a:off x="3904487" y="822960"/>
+            <a:ext cx="3474720" cy="50292"/>
+          </a:xfrm>
+          <a:prstGeom prst="rect">
+            <a:avLst/>
+          </a:prstGeom>
+          <a:solidFill>
+            <a:srgbClr val="1A3460"/>
+          </a:solidFill>
+          <a:ln>
+            <a:noFill/>
+          </a:ln>
+        </p:spPr>
+        <p:style>
+          <a:lnRef idx="1">
+            <a:schemeClr val="accent1"/>
+          </a:lnRef>
+          <a:fillRef idx="3">
+            <a:schemeClr val="accent1"/>
+          </a:fillRef>
+          <a:effectRef idx="2">
+            <a:schemeClr val="accent1"/>
+          </a:effectRef>
+          <a:fontRef idx="minor">
+            <a:schemeClr val="lt1"/>
+          </a:fontRef>
+        </p:style>
+        <p:txBody>
+          <a:bodyPr rtlCol="0" anchor="ctr"/>
+          <a:lstStyle/>
+          <a:p>
+            <a:pPr algn="ctr"/>
+          </a:p>
+        </p:txBody>
+      </p:sp>
+      <p:sp>
+        <p:nvSpPr>
+          <p:cNvPr id="17" name="TextBox 16"/>
+          <p:cNvSpPr txBox="1"/>
+          <p:nvPr/>
+        </p:nvSpPr>
+        <p:spPr>
+          <a:xfrm>
+            <a:off x="4069079" y="914400"/>
+            <a:ext cx="3246120" cy="256032"/>
+          </a:xfrm>
+          <a:prstGeom prst="rect">
+            <a:avLst/>
+          </a:prstGeom>
+          <a:noFill/>
+        </p:spPr>
+        <p:txBody>
+          <a:bodyPr wrap="square">
+            <a:spAutoFit/>
+          </a:bodyPr>
+          <a:lstStyle/>
+          <a:p>
+            <a:pPr algn="l"/>
+            <a:r>
+              <a:rPr sz="900" b="0" i="0">
+                <a:solidFill>
+                  <a:srgbClr val="6B7280"/>
+                </a:solidFill>
+                <a:latin typeface="メイリオ"/>
+              </a:rPr>
+              <a:t>上限年齢 中央値</a:t>
+            </a:r>
+          </a:p>
+        </p:txBody>
+      </p:sp>
+      <p:sp>
+        <p:nvSpPr>
+          <p:cNvPr id="18" name="TextBox 17"/>
+          <p:cNvSpPr txBox="1"/>
+          <p:nvPr/>
+        </p:nvSpPr>
+        <p:spPr>
+          <a:xfrm>
+            <a:off x="4069079" y="1170432"/>
+            <a:ext cx="2971800" cy="457200"/>
+          </a:xfrm>
+          <a:prstGeom prst="rect">
+            <a:avLst/>
+          </a:prstGeom>
+          <a:noFill/>
+        </p:spPr>
+        <p:txBody>
+          <a:bodyPr wrap="square">
+            <a:spAutoFit/>
+          </a:bodyPr>
+          <a:lstStyle/>
+          <a:p>
+            <a:pPr algn="l"/>
+            <a:r>
+              <a:rPr sz="2600" b="1" i="0">
+                <a:solidFill>
+                  <a:srgbClr val="1A3460"/>
+                </a:solidFill>
+                <a:latin typeface="メイリオ"/>
+              </a:rPr>
+              <a:t>35</a:t>
+            </a:r>
+          </a:p>
+        </p:txBody>
+      </p:sp>
+      <p:sp>
+        <p:nvSpPr>
+          <p:cNvPr id="19" name="TextBox 18"/>
+          <p:cNvSpPr txBox="1"/>
+          <p:nvPr/>
+        </p:nvSpPr>
+        <p:spPr>
+          <a:xfrm>
+            <a:off x="4416551" y="1325880"/>
+            <a:ext cx="1097280" cy="256032"/>
+          </a:xfrm>
+          <a:prstGeom prst="rect">
+            <a:avLst/>
+          </a:prstGeom>
+          <a:noFill/>
+        </p:spPr>
+        <p:txBody>
+          <a:bodyPr wrap="square">
+            <a:spAutoFit/>
+          </a:bodyPr>
+          <a:lstStyle/>
+          <a:p>
+            <a:pPr algn="l"/>
+            <a:r>
+              <a:rPr sz="1100" b="0" i="0">
+                <a:solidFill>
+                  <a:srgbClr val="6B7280"/>
+                </a:solidFill>
+                <a:latin typeface="メイリオ"/>
+              </a:rPr>
+              <a:t>歳</a:t>
+            </a:r>
+          </a:p>
+        </p:txBody>
+      </p:sp>
+      <p:sp>
+        <p:nvSpPr>
+          <p:cNvPr id="20" name="Rectangle 19"/>
+          <p:cNvSpPr/>
+          <p:nvPr/>
+        </p:nvSpPr>
+        <p:spPr>
+          <a:xfrm>
+            <a:off x="7607808" y="822960"/>
+            <a:ext cx="3474720" cy="914400"/>
+          </a:xfrm>
+          <a:prstGeom prst="rect">
+            <a:avLst/>
+          </a:prstGeom>
+          <a:solidFill>
+            <a:srgbClr val="FFFFFF"/>
+          </a:solidFill>
+          <a:ln>
+            <a:solidFill>
+              <a:srgbClr val="D1D5DB"/>
+            </a:solidFill>
+          </a:ln>
+        </p:spPr>
+        <p:style>
+          <a:lnRef idx="1">
+            <a:schemeClr val="accent1"/>
+          </a:lnRef>
+          <a:fillRef idx="3">
+            <a:schemeClr val="accent1"/>
+          </a:fillRef>
+          <a:effectRef idx="2">
+            <a:schemeClr val="accent1"/>
+          </a:effectRef>
+          <a:fontRef idx="minor">
+            <a:schemeClr val="lt1"/>
+          </a:fontRef>
+        </p:style>
+        <p:txBody>
+          <a:bodyPr rtlCol="0" anchor="ctr"/>
+          <a:lstStyle/>
+          <a:p>
+            <a:pPr algn="ctr"/>
+          </a:p>
+        </p:txBody>
+      </p:sp>
+      <p:sp>
+        <p:nvSpPr>
+          <p:cNvPr id="21" name="Rectangle 20"/>
+          <p:cNvSpPr/>
+          <p:nvPr/>
+        </p:nvSpPr>
+        <p:spPr>
+          <a:xfrm>
+            <a:off x="7607808" y="822960"/>
+            <a:ext cx="3474720" cy="50292"/>
+          </a:xfrm>
+          <a:prstGeom prst="rect">
+            <a:avLst/>
+          </a:prstGeom>
+          <a:solidFill>
+            <a:srgbClr val="10B981"/>
+          </a:solidFill>
+          <a:ln>
+            <a:noFill/>
+          </a:ln>
+        </p:spPr>
+        <p:style>
+          <a:lnRef idx="1">
+            <a:schemeClr val="accent1"/>
+          </a:lnRef>
+          <a:fillRef idx="3">
+            <a:schemeClr val="accent1"/>
+          </a:fillRef>
+          <a:effectRef idx="2">
+            <a:schemeClr val="accent1"/>
+          </a:effectRef>
+          <a:fontRef idx="minor">
+            <a:schemeClr val="lt1"/>
+          </a:fontRef>
+        </p:style>
+        <p:txBody>
+          <a:bodyPr rtlCol="0" anchor="ctr"/>
+          <a:lstStyle/>
+          <a:p>
+            <a:pPr algn="ctr"/>
+          </a:p>
+        </p:txBody>
+      </p:sp>
+      <p:sp>
+        <p:nvSpPr>
+          <p:cNvPr id="22" name="TextBox 21"/>
+          <p:cNvSpPr txBox="1"/>
+          <p:nvPr/>
+        </p:nvSpPr>
+        <p:spPr>
+          <a:xfrm>
+            <a:off x="7772400" y="914400"/>
+            <a:ext cx="3246120" cy="256032"/>
+          </a:xfrm>
+          <a:prstGeom prst="rect">
+            <a:avLst/>
+          </a:prstGeom>
+          <a:noFill/>
+        </p:spPr>
+        <p:txBody>
+          <a:bodyPr wrap="square">
+            <a:spAutoFit/>
+          </a:bodyPr>
+          <a:lstStyle/>
+          <a:p>
+            <a:pPr algn="l"/>
+            <a:r>
+              <a:rPr sz="900" b="0" i="0">
+                <a:solidFill>
+                  <a:srgbClr val="6B7280"/>
+                </a:solidFill>
+                <a:latin typeface="メイリオ"/>
+              </a:rPr>
+              <a:t>年齢不問 記載率</a:t>
+            </a:r>
+          </a:p>
+        </p:txBody>
+      </p:sp>
+      <p:sp>
+        <p:nvSpPr>
+          <p:cNvPr id="23" name="TextBox 22"/>
+          <p:cNvSpPr txBox="1"/>
+          <p:nvPr/>
+        </p:nvSpPr>
+        <p:spPr>
+          <a:xfrm>
+            <a:off x="7772400" y="1170432"/>
+            <a:ext cx="2971800" cy="457200"/>
+          </a:xfrm>
+          <a:prstGeom prst="rect">
+            <a:avLst/>
+          </a:prstGeom>
+          <a:noFill/>
+        </p:spPr>
+        <p:txBody>
+          <a:bodyPr wrap="square">
+            <a:spAutoFit/>
+          </a:bodyPr>
+          <a:lstStyle/>
+          <a:p>
+            <a:pPr algn="l"/>
+            <a:r>
+              <a:rPr sz="2600" b="1" i="0">
+                <a:solidFill>
+                  <a:srgbClr val="1A3460"/>
+                </a:solidFill>
+                <a:latin typeface="メイリオ"/>
+              </a:rPr>
+              <a:t>0.0</a:t>
+            </a:r>
+          </a:p>
+        </p:txBody>
+      </p:sp>
+      <p:sp>
+        <p:nvSpPr>
+          <p:cNvPr id="24" name="TextBox 23"/>
+          <p:cNvSpPr txBox="1"/>
+          <p:nvPr/>
+        </p:nvSpPr>
+        <p:spPr>
+          <a:xfrm>
+            <a:off x="8293608" y="1325880"/>
+            <a:ext cx="1097280" cy="256032"/>
+          </a:xfrm>
+          <a:prstGeom prst="rect">
+            <a:avLst/>
+          </a:prstGeom>
+          <a:noFill/>
+        </p:spPr>
+        <p:txBody>
+          <a:bodyPr wrap="square">
+            <a:spAutoFit/>
+          </a:bodyPr>
+          <a:lstStyle/>
+          <a:p>
+            <a:pPr algn="l"/>
+            <a:r>
+              <a:rPr sz="1100" b="0" i="0">
+                <a:solidFill>
+                  <a:srgbClr val="6B7280"/>
+                </a:solidFill>
+                <a:latin typeface="メイリオ"/>
+              </a:rPr>
+              <a:t>%</a:t>
+            </a:r>
+          </a:p>
+        </p:txBody>
+      </p:sp>
+      <p:sp>
+        <p:nvSpPr>
+          <p:cNvPr id="25" name="Rectangle 24"/>
+          <p:cNvSpPr/>
+          <p:nvPr/>
+        </p:nvSpPr>
+        <p:spPr>
+          <a:xfrm>
+            <a:off x="201168" y="1901952"/>
+            <a:ext cx="5760720" cy="292608"/>
+          </a:xfrm>
+          <a:prstGeom prst="rect">
+            <a:avLst/>
+          </a:prstGeom>
+          <a:solidFill>
+            <a:srgbClr val="EFF6FF"/>
+          </a:solidFill>
+          <a:ln>
+            <a:noFill/>
+          </a:ln>
+        </p:spPr>
+        <p:style>
+          <a:lnRef idx="1">
+            <a:schemeClr val="accent1"/>
+          </a:lnRef>
+          <a:fillRef idx="3">
+            <a:schemeClr val="accent1"/>
+          </a:fillRef>
+          <a:effectRef idx="2">
+            <a:schemeClr val="accent1"/>
+          </a:effectRef>
+          <a:fontRef idx="minor">
+            <a:schemeClr val="lt1"/>
+          </a:fontRef>
+        </p:style>
+        <p:txBody>
+          <a:bodyPr rtlCol="0" anchor="ctr"/>
+          <a:lstStyle/>
+          <a:p>
+            <a:pPr algn="ctr"/>
+          </a:p>
+        </p:txBody>
+      </p:sp>
+      <p:sp>
+        <p:nvSpPr>
+          <p:cNvPr id="26" name="TextBox 25"/>
+          <p:cNvSpPr txBox="1"/>
+          <p:nvPr/>
+        </p:nvSpPr>
+        <p:spPr>
+          <a:xfrm>
+            <a:off x="338328" y="1938528"/>
+            <a:ext cx="5577840" cy="228600"/>
+          </a:xfrm>
+          <a:prstGeom prst="rect">
+            <a:avLst/>
+          </a:prstGeom>
+          <a:noFill/>
+        </p:spPr>
+        <p:txBody>
+          <a:bodyPr wrap="square">
+            <a:spAutoFit/>
+          </a:bodyPr>
+          <a:lstStyle/>
+          <a:p>
+            <a:pPr algn="l"/>
+            <a:r>
+              <a:rPr sz="1000" b="1" i="0">
+                <a:solidFill>
+                  <a:srgbClr val="2163EB"/>
+                </a:solidFill>
+                <a:latin typeface="メイリオ"/>
+              </a:rPr>
+              <a:t>年齢上限 分布（記載あり求人のみ）</a:t>
+            </a:r>
+          </a:p>
+        </p:txBody>
+      </p:sp>
+      <p:pic>
+        <p:nvPicPr>
+          <p:cNvPr id="27" name="Picture 26" descr="image.png"/>
+          <p:cNvPicPr>
+            <a:picLocks noChangeAspect="1"/>
+          </p:cNvPicPr>
+          <p:nvPr/>
+        </p:nvPicPr>
+        <p:blipFill>
+          <a:blip r:embed="rId2"/>
+          <a:stretch>
+            <a:fillRect/>
+          </a:stretch>
+        </p:blipFill>
+        <p:spPr>
+          <a:xfrm>
+            <a:off x="201168" y="2212848"/>
+            <a:ext cx="5760720" cy="4114800"/>
+          </a:xfrm>
+          <a:prstGeom prst="rect">
+            <a:avLst/>
+          </a:prstGeom>
+        </p:spPr>
+      </p:pic>
+      <p:sp>
+        <p:nvSpPr>
+          <p:cNvPr id="28" name="Rectangle 27"/>
+          <p:cNvSpPr/>
+          <p:nvPr/>
+        </p:nvSpPr>
+        <p:spPr>
+          <a:xfrm>
+            <a:off x="5961888" y="1901952"/>
+            <a:ext cx="6035040" cy="292608"/>
+          </a:xfrm>
+          <a:prstGeom prst="rect">
+            <a:avLst/>
+          </a:prstGeom>
+          <a:solidFill>
+            <a:srgbClr val="EFF6FF"/>
+          </a:solidFill>
+          <a:ln>
+            <a:noFill/>
+          </a:ln>
+        </p:spPr>
+        <p:style>
+          <a:lnRef idx="1">
+            <a:schemeClr val="accent1"/>
+          </a:lnRef>
+          <a:fillRef idx="3">
+            <a:schemeClr val="accent1"/>
+          </a:fillRef>
+          <a:effectRef idx="2">
+            <a:schemeClr val="accent1"/>
+          </a:effectRef>
+          <a:fontRef idx="minor">
+            <a:schemeClr val="lt1"/>
+          </a:fontRef>
+        </p:style>
+        <p:txBody>
+          <a:bodyPr rtlCol="0" anchor="ctr"/>
+          <a:lstStyle/>
+          <a:p>
+            <a:pPr algn="ctr"/>
+          </a:p>
+        </p:txBody>
+      </p:sp>
+      <p:sp>
+        <p:nvSpPr>
+          <p:cNvPr id="29" name="TextBox 28"/>
+          <p:cNvSpPr txBox="1"/>
+          <p:nvPr/>
+        </p:nvSpPr>
+        <p:spPr>
+          <a:xfrm>
+            <a:off x="6099048" y="1938528"/>
+            <a:ext cx="5852159" cy="228600"/>
+          </a:xfrm>
+          <a:prstGeom prst="rect">
+            <a:avLst/>
+          </a:prstGeom>
+          <a:noFill/>
+        </p:spPr>
+        <p:txBody>
+          <a:bodyPr wrap="square">
+            <a:spAutoFit/>
+          </a:bodyPr>
+          <a:lstStyle/>
+          <a:p>
+            <a:pPr algn="l"/>
+            <a:r>
+              <a:rPr sz="1000" b="1" i="0">
+                <a:solidFill>
+                  <a:srgbClr val="1A3460"/>
+                </a:solidFill>
+                <a:latin typeface="メイリオ"/>
+              </a:rPr>
+              <a:t>世代・年齢訴求キーワード 記載率</a:t>
+            </a:r>
+          </a:p>
+        </p:txBody>
+      </p:sp>
+      <p:pic>
+        <p:nvPicPr>
+          <p:cNvPr id="30" name="Picture 29" descr="image.png"/>
+          <p:cNvPicPr>
+            <a:picLocks noChangeAspect="1"/>
+          </p:cNvPicPr>
+          <p:nvPr/>
+        </p:nvPicPr>
+        <p:blipFill>
+          <a:blip r:embed="rId3"/>
+          <a:stretch>
+            <a:fillRect/>
+          </a:stretch>
+        </p:blipFill>
+        <p:spPr>
+          <a:xfrm>
+            <a:off x="5961888" y="2212848"/>
+            <a:ext cx="6035040" cy="2103120"/>
+          </a:xfrm>
+          <a:prstGeom prst="rect">
+            <a:avLst/>
+          </a:prstGeom>
+        </p:spPr>
+      </p:pic>
+      <p:sp>
+        <p:nvSpPr>
+          <p:cNvPr id="31" name="Rectangle 30"/>
+          <p:cNvSpPr/>
+          <p:nvPr/>
+        </p:nvSpPr>
+        <p:spPr>
+          <a:xfrm>
+            <a:off x="5961888" y="4407408"/>
+            <a:ext cx="6035040" cy="292608"/>
+          </a:xfrm>
+          <a:prstGeom prst="rect">
+            <a:avLst/>
+          </a:prstGeom>
+          <a:solidFill>
+            <a:srgbClr val="F3F4F6"/>
+          </a:solidFill>
+          <a:ln>
+            <a:noFill/>
+          </a:ln>
+        </p:spPr>
+        <p:style>
+          <a:lnRef idx="1">
+            <a:schemeClr val="accent1"/>
+          </a:lnRef>
+          <a:fillRef idx="3">
+            <a:schemeClr val="accent1"/>
+          </a:fillRef>
+          <a:effectRef idx="2">
+            <a:schemeClr val="accent1"/>
+          </a:effectRef>
+          <a:fontRef idx="minor">
+            <a:schemeClr val="lt1"/>
+          </a:fontRef>
+        </p:style>
+        <p:txBody>
+          <a:bodyPr rtlCol="0" anchor="ctr"/>
+          <a:lstStyle/>
+          <a:p>
+            <a:pPr algn="ctr"/>
+          </a:p>
+        </p:txBody>
+      </p:sp>
+      <p:sp>
+        <p:nvSpPr>
+          <p:cNvPr id="32" name="TextBox 31"/>
+          <p:cNvSpPr txBox="1"/>
+          <p:nvPr/>
+        </p:nvSpPr>
+        <p:spPr>
+          <a:xfrm>
+            <a:off x="6099048" y="4443984"/>
+            <a:ext cx="5852159" cy="228600"/>
+          </a:xfrm>
+          <a:prstGeom prst="rect">
+            <a:avLst/>
+          </a:prstGeom>
+          <a:noFill/>
+        </p:spPr>
+        <p:txBody>
+          <a:bodyPr wrap="square">
+            <a:spAutoFit/>
+          </a:bodyPr>
+          <a:lstStyle/>
+          <a:p>
+            <a:pPr algn="l"/>
+            <a:r>
+              <a:rPr sz="1000" b="1" i="0">
+                <a:solidFill>
+                  <a:srgbClr val="6B7280"/>
+                </a:solidFill>
+                <a:latin typeface="メイリオ"/>
+              </a:rPr>
+              <a:t>職種別 年齢上限 中央値（記載あり）</a:t>
+            </a:r>
+          </a:p>
+        </p:txBody>
+      </p:sp>
+      <p:pic>
+        <p:nvPicPr>
+          <p:cNvPr id="33" name="Picture 32" descr="image.png"/>
+          <p:cNvPicPr>
+            <a:picLocks noChangeAspect="1"/>
+          </p:cNvPicPr>
+          <p:nvPr/>
+        </p:nvPicPr>
+        <p:blipFill>
+          <a:blip r:embed="rId4"/>
+          <a:stretch>
+            <a:fillRect/>
+          </a:stretch>
+        </p:blipFill>
+        <p:spPr>
+          <a:xfrm>
+            <a:off x="5961888" y="4718304"/>
+            <a:ext cx="6035040" cy="1828800"/>
           </a:xfrm>
           <a:prstGeom prst="rect">
             <a:avLst/>

</xml_diff>